<commit_message>
Revisione stage 1: SoA, organigramma, rischi ed elenco documenti
- SoA rev 0.4-0.5: Applicabile/Applicato e motivi per i 93 controlli dall'export
  ERA; rimossa la sezione AGID CSP-SAAS di un altro cliente.
- Organigramma ALPO01.A rev 0.1 e Mansionario ALPO01.B rev 0.2.
- PR33.1 rev 0.1, report e piano di trattamento dei rischi 2026 rev 0.1.
- Elenco informazioni documentate generato da tools/genera_elenco.py, eseguito
  anche nella pipeline prima della pubblicazione; PR08.1 rev 0.2.
- Workflow di deploy: rimosso il contenuto duplicato che rendeva il file non valido.
- Aggiornati STATO-PROGETTO.md e la dashboard documentale.

Co-Authored-By: Claude Opus 5.5 <noreply@anthropic.com>
</commit_message>
<xml_diff>
--- a/docs/01_POLITICA SISTEMA INTEGRATO/ALPO01.A - Organigramma-Rev 0.0.pptx
+++ b/docs/01_POLITICA SISTEMA INTEGRATO/ALPO01.A - Organigramma-Rev 0.0.pptx
@@ -14069,7 +14069,7 @@
                 <a:cs typeface="Arial"/>
                 <a:sym typeface="Arial"/>
               </a:rPr>
-              <a:t>CdA</a:t>
+              <a:t>Amministratore Unico</a:t>
             </a:r>
             <a:endParaRPr b="1" i="0" sz="1100" u="none" cap="none" strike="noStrike">
               <a:solidFill>
@@ -14405,8 +14405,8 @@
         </p:nvSpPr>
         <p:spPr>
           <a:xfrm>
-            <a:off x="7359975" y="2771413"/>
-            <a:ext cx="1355700" cy="660600"/>
+            <a:off x="7359975" y="2701413"/>
+            <a:ext cx="1415700" cy="800600"/>
           </a:xfrm>
           <a:prstGeom prst="rect">
             <a:avLst/>
@@ -14455,7 +14455,7 @@
                 <a:cs typeface="Arial"/>
                 <a:sym typeface="Arial"/>
               </a:rPr>
-              <a:t>Amministrazion</a:t>
+              <a:t>Amministrazione, HR</a:t>
             </a:r>
             <a:r>
               <a:rPr b="1" lang="it-IT" sz="1100">
@@ -14463,7 +14463,7 @@
                   <a:schemeClr val="dk1"/>
                 </a:solidFill>
               </a:rPr>
-              <a:t>e</a:t>
+              <a:t/>
             </a:r>
             <a:r>
               <a:rPr b="1" i="0" lang="it-IT" sz="1100" u="none" cap="none" strike="noStrike">
@@ -14475,7 +14475,7 @@
                 <a:cs typeface="Arial"/>
                 <a:sym typeface="Arial"/>
               </a:rPr>
-              <a:t>  HR</a:t>
+              <a:t/>
             </a:r>
             <a:endParaRPr b="1" i="0" sz="1100" u="none" cap="none" strike="noStrike">
               <a:solidFill>
@@ -14515,7 +14515,7 @@
                 <a:cs typeface="Arial"/>
                 <a:sym typeface="Arial"/>
               </a:rPr>
-              <a:t>Francesco Cappetti</a:t>
+              <a:t>Francesco Cappetti (Ref. Privacy)</a:t>
             </a:r>
             <a:endParaRPr b="1" i="0" sz="1100" u="none" cap="none" strike="noStrike">
               <a:solidFill>
@@ -14587,7 +14587,7 @@
                 <a:cs typeface="Arial"/>
                 <a:sym typeface="Arial"/>
               </a:rPr>
-              <a:t>IT</a:t>
+              <a:t>IT (esterno)</a:t>
             </a:r>
             <a:endParaRPr/>
           </a:p>
@@ -15709,7 +15709,7 @@
                 <a:cs typeface="Arial"/>
                 <a:sym typeface="Arial"/>
               </a:rPr>
-              <a:t>Rev 0.0   -   14/4/2026</a:t>
+              <a:t>Rev 0.1   -   20/10/2026</a:t>
             </a:r>
             <a:endParaRPr b="0" i="0" sz="1400" u="none" cap="none" strike="noStrike">
               <a:solidFill>
@@ -15833,7 +15833,7 @@
                 <a:cs typeface="Arial"/>
                 <a:sym typeface="Arial"/>
               </a:rPr>
-              <a:t>Marco Ottone</a:t>
+              <a:t>Marco Ottone Casagrande</a:t>
             </a:r>
             <a:endParaRPr b="1" i="0" sz="1100" u="none" cap="none" strike="noStrike">
               <a:solidFill>

</xml_diff>